<commit_message>
build: deliver materials matching the confirmed four-part responsibilities
</commit_message>
<xml_diff>
--- a/submission/Group5_Presentation.pptx
+++ b/submission/Group5_Presentation.pptx
@@ -787,6 +787,254 @@
     <c:autoTitleDeleted val="1"/>
     <c:plotArea>
       <c:barChart>
+        <c:barDir val="bar"/>
+        <c:grouping val="clustered"/>
+        <c:ser>
+          <c:idx val="0"/>
+          <c:order val="0"/>
+          <c:tx>
+            <c:strRef>
+              <c:f>Sheet1!$B$1</c:f>
+              <c:strCache>
+                <c:ptCount val="1"/>
+                <c:pt idx="0">
+                  <c:v>Mean AP decrease</c:v>
+                </c:pt>
+              </c:strCache>
+            </c:strRef>
+          </c:tx>
+          <c:spPr>
+            <a:solidFill>
+              <a:srgbClr val="899CA5"/>
+            </a:solidFill>
+            <a:ln>
+              <a:noFill/>
+            </a:ln>
+          </c:spPr>
+          <c:dPt>
+            <c:idx val="0"/>
+            <c:spPr>
+              <a:solidFill>
+                <a:srgbClr val="187B78"/>
+              </a:solidFill>
+              <a:ln>
+                <a:noFill/>
+              </a:ln>
+            </c:spPr>
+          </c:dPt>
+          <c:dPt>
+            <c:idx val="1"/>
+            <c:spPr>
+              <a:solidFill>
+                <a:srgbClr val="187B78"/>
+              </a:solidFill>
+              <a:ln>
+                <a:noFill/>
+              </a:ln>
+            </c:spPr>
+          </c:dPt>
+          <c:dPt>
+            <c:idx val="2"/>
+            <c:spPr>
+              <a:solidFill>
+                <a:srgbClr val="187B78"/>
+              </a:solidFill>
+              <a:ln>
+                <a:noFill/>
+              </a:ln>
+            </c:spPr>
+          </c:dPt>
+          <c:dPt>
+            <c:idx val="3"/>
+            <c:spPr>
+              <a:solidFill>
+                <a:srgbClr val="187B78"/>
+              </a:solidFill>
+              <a:ln>
+                <a:noFill/>
+              </a:ln>
+            </c:spPr>
+          </c:dPt>
+          <c:dPt>
+            <c:idx val="4"/>
+            <c:spPr>
+              <a:solidFill>
+                <a:srgbClr val="187B78"/>
+              </a:solidFill>
+              <a:ln>
+                <a:noFill/>
+              </a:ln>
+            </c:spPr>
+          </c:dPt>
+          <c:cat>
+            <c:strRef>
+              <c:f>Sheet1!$A$2:$A$6</c:f>
+              <c:strCache>
+                <c:ptCount val="5"/>
+                <c:pt idx="0">
+                  <c:v>BILL_AMT1</c:v>
+                </c:pt>
+                <c:pt idx="1">
+                  <c:v>LIMIT_BAL</c:v>
+                </c:pt>
+                <c:pt idx="2">
+                  <c:v>PAY_3</c:v>
+                </c:pt>
+                <c:pt idx="3">
+                  <c:v>PAY_2</c:v>
+                </c:pt>
+                <c:pt idx="4">
+                  <c:v>PAY_0</c:v>
+                </c:pt>
+              </c:strCache>
+            </c:strRef>
+          </c:cat>
+          <c:val>
+            <c:numRef>
+              <c:f>Sheet1!$B$2:$B$6</c:f>
+              <c:numCache>
+                <c:formatCode>General</c:formatCode>
+                <c:ptCount val="5"/>
+                <c:pt idx="0">
+                  <c:v>0.008748613100078417</c:v>
+                </c:pt>
+                <c:pt idx="1">
+                  <c:v>0.010001940536327946</c:v>
+                </c:pt>
+                <c:pt idx="2">
+                  <c:v>0.010869789890604298</c:v>
+                </c:pt>
+                <c:pt idx="3">
+                  <c:v>0.019572348649687286</c:v>
+                </c:pt>
+                <c:pt idx="4">
+                  <c:v>0.19707230912780407</c:v>
+                </c:pt>
+              </c:numCache>
+            </c:numRef>
+          </c:val>
+        </c:ser>
+        <c:dLbls>
+          <c:numFmt formatCode="0.000" sourceLinked="0"/>
+          <c:txPr>
+            <a:bodyPr/>
+            <a:lstStyle/>
+            <a:p>
+              <a:pPr>
+                <a:defRPr sz="1700"/>
+              </a:pPr>
+            </a:p>
+          </c:txPr>
+          <c:dLblPos val="outEnd"/>
+          <c:showLegendKey val="0"/>
+          <c:showVal val="1"/>
+          <c:showCatName val="0"/>
+          <c:showSerName val="0"/>
+          <c:showPercent val="0"/>
+          <c:showBubbleSize val="0"/>
+          <c:showLeaderLines val="1"/>
+        </c:dLbls>
+        <c:gapWidth val="90"/>
+        <c:axId val="-2068027336"/>
+        <c:axId val="-2113994440"/>
+      </c:barChart>
+      <c:catAx>
+        <c:axId val="-2068027336"/>
+        <c:scaling>
+          <c:orientation val="minMax"/>
+        </c:scaling>
+        <c:delete val="0"/>
+        <c:axPos val="l"/>
+        <c:majorTickMark val="out"/>
+        <c:minorTickMark val="none"/>
+        <c:tickLblPos val="nextTo"/>
+        <c:spPr>
+          <a:ln>
+            <a:solidFill>
+              <a:srgbClr val="E1E8E8"/>
+            </a:solidFill>
+          </a:ln>
+        </c:spPr>
+        <c:txPr>
+          <a:bodyPr/>
+          <a:lstStyle/>
+          <a:p>
+            <a:pPr>
+              <a:defRPr sz="1600"/>
+            </a:pPr>
+          </a:p>
+        </c:txPr>
+        <c:crossAx val="-2113994440"/>
+        <c:crosses val="autoZero"/>
+        <c:auto val="1"/>
+        <c:lblAlgn val="ctr"/>
+        <c:lblOffset val="100"/>
+        <c:noMultiLvlLbl val="0"/>
+      </c:catAx>
+      <c:valAx>
+        <c:axId val="-2113994440"/>
+        <c:scaling>
+          <c:max val="0.24"/>
+          <c:min val="0.0"/>
+        </c:scaling>
+        <c:delete val="0"/>
+        <c:axPos val="b"/>
+        <c:majorGridlines>
+          <c:spPr>
+            <a:ln>
+              <a:solidFill>
+                <a:srgbClr val="E1E8E8"/>
+              </a:solidFill>
+            </a:ln>
+          </c:spPr>
+        </c:majorGridlines>
+        <c:numFmt formatCode="0.000" sourceLinked="0"/>
+        <c:majorTickMark val="out"/>
+        <c:minorTickMark val="none"/>
+        <c:tickLblPos val="nextTo"/>
+        <c:spPr>
+          <a:ln>
+            <a:noFill/>
+          </a:ln>
+        </c:spPr>
+        <c:txPr>
+          <a:bodyPr/>
+          <a:lstStyle/>
+          <a:p>
+            <a:pPr>
+              <a:defRPr sz="1400"/>
+            </a:pPr>
+          </a:p>
+        </c:txPr>
+        <c:crossAx val="-2068027336"/>
+        <c:crosses val="autoZero"/>
+      </c:valAx>
+    </c:plotArea>
+    <c:dispBlanksAs val="gap"/>
+  </c:chart>
+  <c:txPr>
+    <a:bodyPr/>
+    <a:lstStyle/>
+    <a:p>
+      <a:pPr>
+        <a:defRPr sz="1800"/>
+      </a:pPr>
+      <a:endParaRPr lang="en-US"/>
+    </a:p>
+  </c:txPr>
+  <c:externalData r:id="rId1">
+    <c:autoUpdate val="0"/>
+  </c:externalData>
+</c:chartSpace>
+</file>
+
+<file path=ppt/charts/chart5.xml><?xml version="1.0" encoding="utf-8"?>
+<c:chartSpace xmlns:c="http://schemas.openxmlformats.org/drawingml/2006/chart" xmlns:a="http://schemas.openxmlformats.org/drawingml/2006/main" xmlns:r="http://schemas.openxmlformats.org/officeDocument/2006/relationships">
+  <c:date1904 val="0"/>
+  <c:chart>
+    <c:autoTitleDeleted val="1"/>
+    <c:plotArea>
+      <c:barChart>
         <c:barDir val="col"/>
         <c:grouping val="clustered"/>
         <c:ser>
@@ -977,7 +1225,7 @@
 </c:chartSpace>
 </file>
 
-<file path=ppt/charts/chart5.xml><?xml version="1.0" encoding="utf-8"?>
+<file path=ppt/charts/chart6.xml><?xml version="1.0" encoding="utf-8"?>
 <c:chartSpace xmlns:c="http://schemas.openxmlformats.org/drawingml/2006/chart" xmlns:a="http://schemas.openxmlformats.org/drawingml/2006/main" xmlns:r="http://schemas.openxmlformats.org/officeDocument/2006/relationships">
   <c:date1904 val="0"/>
   <c:chart>
@@ -1715,7 +1963,7 @@
           </a:p>
           <a:p>
             <a:r>
-              <a:t>Xu Yiqun (G2509092H) | Part 4: XGBoost and cost analysis | Contribution 25%</a:t>
+              <a:t>Xu Yiqun (G2509092H) | Part 4: XGBoost and threshold trade-offs | Contribution 25%</a:t>
             </a:r>
           </a:p>
           <a:p>
@@ -1813,7 +2061,7 @@
           </a:p>
           <a:p>
             <a:r>
-              <a:t>Xu Yiqun (G2509092H) | Part 4: XGBoost and cost analysis | Contribution 25%</a:t>
+              <a:t>Xu Yiqun (G2509092H) | Part 4: XGBoost and threshold trade-offs | Contribution 25%</a:t>
             </a:r>
           </a:p>
           <a:p>
@@ -1911,7 +2159,7 @@
           </a:p>
           <a:p>
             <a:r>
-              <a:t>Xu Yiqun (G2509092H) | Part 4: XGBoost and cost analysis | Contribution 25%</a:t>
+              <a:t>Xu Yiqun (G2509092H) | Part 4: XGBoost and threshold trade-offs | Contribution 25%</a:t>
             </a:r>
           </a:p>
           <a:p>
@@ -2009,7 +2257,7 @@
           </a:p>
           <a:p>
             <a:r>
-              <a:t>Zhang Hanyu (G2509091L) | Part 2: Decision tree and model comparison | Contribution 25%</a:t>
+              <a:t>Zhang Hanyu (G2509091L) | Part 2: Decision tree and overfitting | Contribution 25%</a:t>
             </a:r>
           </a:p>
           <a:p>
@@ -2107,7 +2355,7 @@
           </a:p>
           <a:p>
             <a:r>
-              <a:t>Xu Yiqun (G2509092H) | Part 4: XGBoost and cost analysis | Contribution 25%</a:t>
+              <a:t>Xu Yiqun (G2509092H) | Part 4: XGBoost and threshold trade-offs | Contribution 25%</a:t>
             </a:r>
           </a:p>
           <a:p>
@@ -2303,7 +2551,7 @@
           </a:p>
           <a:p>
             <a:r>
-              <a:t>Zhou Xinzhe (G2509033F) | Part 3: Random forest and experiment audit | Contribution 25%</a:t>
+              <a:t>Zhou Xinzhe (G2509033F) | Part 3: Random forest and error analysis | Contribution 25%</a:t>
             </a:r>
           </a:p>
           <a:p>
@@ -2314,7 +2562,7 @@
           <a:p/>
           <a:p>
             <a:r>
-              <a:t>The numerical source for this editable presentation is the audited final comparison CSV, with model-specific protocols and bootstrap artifacts supplying supporting context. The UCI dataset, scikit-learn average-precision documentation, and the XGBoost paper are the core external references. The role plan assigns three minutes each to data and logistic regression, decision trees and ranking, random forest and audit, and XGBoost and costs. Lei Peng covers part one, Zhang Hanyu part two, Zhou Xinzhe part three, and Xu Yiqun part four. The group has confirmed equal contributions of twenty-five percent each. Integration and the logistic supplement were prepared with AI assistance for member review. Reproducing artifacts is distinct from retraining and selecting new models.</a:t>
+              <a:t>The numerical source for this editable presentation is the audited final comparison CSV, with model-specific protocols and bootstrap artifacts supplying supporting context. The UCI dataset, scikit-learn average-precision documentation, and the XGBoost paper are the core external references. The role plan assigns three minutes each to data and logistic regression, decision trees and ranking, random forest with feature importance and error cases, and XGBoost with threshold trade-offs. Lei Peng covers part one, Zhang Hanyu part two, Zhou Xinzhe part three, and Xu Yiqun part four. The group has confirmed equal contributions of twenty-five percent each. Data-split and metric agreement, final integration, checking and rehearsal are shared by all four members. Integration and the logistic supplement were prepared with AI assistance for member review. Reproducing artifacts is distinct from retraining and selecting new models.</a:t>
             </a:r>
           </a:p>
           <a:p/>
@@ -2597,7 +2845,7 @@
           </a:p>
           <a:p>
             <a:r>
-              <a:t>Zhang Hanyu (G2509091L) | Part 2: Decision tree and model comparison | Contribution 25%</a:t>
+              <a:t>Zhang Hanyu (G2509091L) | Part 2: Decision tree and overfitting | Contribution 25%</a:t>
             </a:r>
           </a:p>
           <a:p>
@@ -2695,7 +2943,7 @@
           </a:p>
           <a:p>
             <a:r>
-              <a:t>Zhang Hanyu (G2509091L) | Part 2: Decision tree and model comparison | Contribution 25%</a:t>
+              <a:t>Zhang Hanyu (G2509091L) | Part 2: Decision tree and overfitting | Contribution 25%</a:t>
             </a:r>
           </a:p>
           <a:p>
@@ -2793,7 +3041,7 @@
           </a:p>
           <a:p>
             <a:r>
-              <a:t>Zhang Hanyu (G2509091L) | Part 2: Decision tree and model comparison | Contribution 25%</a:t>
+              <a:t>Zhang Hanyu (G2509091L) | Part 2: Decision tree and overfitting | Contribution 25%</a:t>
             </a:r>
           </a:p>
           <a:p>
@@ -2804,13 +3052,13 @@
           <a:p/>
           <a:p>
             <a:r>
-              <a:t>This comparison retains both the baseline and the cross-validation-selected model for each family. Average precision is a recall-increment weighted sum of precision, not the trapezoidal area sometimes also called PR-AUC. Our positive prevalence is approximately zero point two two, which gives useful context for these scores. The selected forest has AP 0.5508, and selected XGBoost has 0.5516. Those close point estimates do not establish superiority. The XGBoost baseline is numerically higher, but this retrospective observation does not authorize another selection round on test results. Part three will examine the forest and the fairness of our comparison.</a:t>
+              <a:t>This comparison retains both the baseline and the cross-validation-selected model for each family. Average precision is a recall-increment weighted sum of precision, not the trapezoidal area sometimes also called PR-AUC. Our positive prevalence is approximately zero point two two, which gives useful context for these scores. The selected forest has AP 0.5508, and selected XGBoost has 0.5516. Those close point estimates do not establish superiority. The XGBoost baseline is numerically higher, but this retrospective observation does not authorize another selection round on test results. Zhou Xinzhe will now explain the forest, its feature importance, and examples of its errors.</a:t>
             </a:r>
           </a:p>
           <a:p/>
           <a:p>
             <a:r>
-              <a:t>Transition: I will now hand over to Zhou Xinzhe for random forest and the comparison audit.</a:t>
+              <a:t>Transition: I will now hand over to Zhou Xinzhe for random forest, feature importance, and error cases.</a:t>
             </a:r>
           </a:p>
           <a:p/>
@@ -2891,7 +3139,7 @@
           </a:p>
           <a:p>
             <a:r>
-              <a:t>Zhou Xinzhe (G2509033F) | Part 3: Random forest and experiment audit | Contribution 25%</a:t>
+              <a:t>Zhou Xinzhe (G2509033F) | Part 3: Random forest and error analysis | Contribution 25%</a:t>
             </a:r>
           </a:p>
           <a:p>
@@ -2902,13 +3150,13 @@
           <a:p/>
           <a:p>
             <a:r>
-              <a:t>Random forest averages many trees, reducing dependence on any single partition. We evaluated a baseline and twenty-three seeded candidate configurations using the same five fitting folds and average-precision objective. The selected configuration uses five hundred trees, maximum depth eight, a minimum leaf size of two, and half the features at each split. It also weights the positive class three times as heavily. Test AP changes from 0.5312 to 0.5508. Class weighting affects the learned score distribution, so we should not assume these scores are calibrated probabilities. We next inspect the operating threshold and the resulting workload rather than relying on ranking alone.</a:t>
+              <a:t>Random forest averages many trees, reducing dependence on any single partition. We evaluated a baseline and twenty-three seeded candidate configurations using the same five fitting folds and average-precision objective. The selected configuration uses five hundred trees, maximum depth eight, a minimum leaf size of two, and half the features at each split. It also weights the positive class three times as heavily. Test AP changes from 0.5312 to 0.5508. Class weighting affects the learned score distribution, so we should not assume these scores are calibrated probabilities. We next examine which features the fitted forest relies on and where it makes errors.</a:t>
             </a:r>
           </a:p>
           <a:p/>
           <a:p>
             <a:r>
-              <a:t>Transition: We next move from the forest's ranking to its decision threshold.</a:t>
+              <a:t>Transition: We next examine which features the forest uses to rank risk.</a:t>
             </a:r>
           </a:p>
           <a:p/>
@@ -2984,12 +3232,12 @@
           <a:lstStyle/>
           <a:p>
             <a:r>
-              <a:t>Slide 8: Random forest: the review workload</a:t>
-            </a:r>
-          </a:p>
-          <a:p>
-            <a:r>
-              <a:t>Zhou Xinzhe (G2509033F) | Part 3: Random forest and experiment audit | Contribution 25%</a:t>
+              <a:t>Slide 8: Random forest: which features matter?</a:t>
+            </a:r>
+          </a:p>
+          <a:p>
+            <a:r>
+              <a:t>Zhou Xinzhe (G2509033F) | Part 3: Random forest and error analysis | Contribution 25%</a:t>
             </a:r>
           </a:p>
           <a:p>
@@ -3000,19 +3248,19 @@
           <a:p/>
           <a:p>
             <a:r>
-              <a:t>For the forest, validation selected a threshold of 0.3229 under the hypothetical assumption that a missed default costs five times a false-positive review. On the historical test set, recall rises from 52.0% to 77.1%, but the alert rate also rises from 21.1% to 48.4%. Cost falls from 3758 to 3404 units. We independently checked the saved error profiles and case rules for both policies. The most confident errors can appear in both exports because they remain errors at both thresholds. Identical extreme examples alone therefore do not demonstrate an export mistake.</a:t>
+              <a:t>We measure importance by shuffling one feature on validation data and observing the fall in average precision. The forest relies most strongly on recent repayment status, PAY zero: its mean AP decrease is 0.1971. Earlier repayment status, PAY two, follows at 0.0196. These values come from five saved permutations of each feature. They describe the fitted forest's predictive reliance, not a causal effect or a feature's isolated contribution. Correlated predictors can substitute for one another, and shuffling may create combinations that do not occur naturally. The chart shows mean decreases; variation across shuffles is recorded in the report. Even an influential variable cannot explain every customer's outcome.</a:t>
             </a:r>
           </a:p>
           <a:p/>
           <a:p>
             <a:r>
-              <a:t>Transition: Before comparing policies, we should check that the underlying evidence aligns.</a:t>
+              <a:t>Transition: We now look at two saved errors to understand the limits of these patterns.</a:t>
             </a:r>
           </a:p>
           <a:p/>
           <a:p>
             <a:r>
-              <a:t>Source: results/final/model_comparison.csv | Historical test n=6,000; default=1 | RF misclassification audit; costs hypothetical.</a:t>
+              <a:t>Source: results/rf/validation_importance.csv | Five validation permutations; frozen model.</a:t>
             </a:r>
           </a:p>
         </p:txBody>
@@ -3082,12 +3330,12 @@
           <a:lstStyle/>
           <a:p>
             <a:r>
-              <a:t>Slide 9: What makes the comparison credible</a:t>
-            </a:r>
-          </a:p>
-          <a:p>
-            <a:r>
-              <a:t>Zhou Xinzhe (G2509033F) | Part 3: Random forest and experiment audit | Contribution 25%</a:t>
+              <a:t>Slide 9: Random forest: two illustrative errors</a:t>
+            </a:r>
+          </a:p>
+          <a:p>
+            <a:r>
+              <a:t>Zhou Xinzhe (G2509033F) | Part 3: Random forest and error analysis | Contribution 25%</a:t>
             </a:r>
           </a:p>
           <a:p>
@@ -3098,7 +3346,7 @@
           <a:p/>
           <a:p>
             <a:r>
-              <a:t>Our audit checks that comparisons use the same clients, labels, development partitions, and five-fold memberships. It recomputes metrics from row-aligned saved predictions and applies the exact greater-than-or-equal decision rule before rounding. Saved-model replay reproduces frozen decisions; minor floating-point differences are documented. These checks make the comparison traceable, but they do not make every aspect identical: search budgets differ, and the logistic supplement has a distinct evidence history. Nor can a repository audit prove everything performed outside the repository. With those boundaries explicit, part four now separates XGBoost's ranking result from its threshold-policy result.</a:t>
+              <a:t>At the fixed threshold of zero point five, the selected forest misses 637 defaults and falsely flags 573 non-defaults. Consider two examples already present in the saved error export. Row 982 actually defaults but receives a score of 0.1012; its recent repayment code is -2. Row 28747 does not default but scores 0.9415; its recent repayment code is 3. These examples show that repayment history is informative but not deterministic. They are the most confident errors from the existing export, not representative average customers. We do not change the model after inspecting them. Xu Yiqun will now examine the separate trade-off created by changing a validation-selected threshold.</a:t>
             </a:r>
           </a:p>
           <a:p/>
@@ -3110,7 +3358,7 @@
           <a:p/>
           <a:p>
             <a:r>
-              <a:t>Source: results/final/audit.json; integration/LOGISTIC_PROVENANCE.md</a:t>
+              <a:t>Source: results/rf/misclassification_cases_05.csv | Tuned RF; score ≥ 0.5 predicts default.</a:t>
             </a:r>
           </a:p>
         </p:txBody>
@@ -6970,7 +7218,7 @@
               </a:defRPr>
             </a:pPr>
             <a:r>
-              <a:t>PART 4  /  Xu Yiqun  /  XGBoost and cost analysis</a:t>
+              <a:t>PART 4  /  Xu Yiqun  /  XGBoost and threshold trade-offs</a:t>
             </a:r>
           </a:p>
         </p:txBody>
@@ -7528,7 +7776,7 @@
               </a:defRPr>
             </a:pPr>
             <a:r>
-              <a:t>PART 4  /  Xu Yiqun  /  XGBoost and cost analysis</a:t>
+              <a:t>PART 4  /  Xu Yiqun  /  XGBoost and threshold trade-offs</a:t>
             </a:r>
           </a:p>
         </p:txBody>
@@ -8086,7 +8334,7 @@
               </a:defRPr>
             </a:pPr>
             <a:r>
-              <a:t>PART 4  /  Xu Yiqun  /  XGBoost and cost analysis</a:t>
+              <a:t>PART 4  /  Xu Yiqun  /  XGBoost and threshold trade-offs</a:t>
             </a:r>
           </a:p>
         </p:txBody>
@@ -8734,7 +8982,7 @@
               </a:defRPr>
             </a:pPr>
             <a:r>
-              <a:t>Q&amp;A BACKUP  /  Zhang Hanyu  /  Decision tree and model comparison</a:t>
+              <a:t>Q&amp;A BACKUP  /  Zhang Hanyu  /  Decision tree and overfitting</a:t>
             </a:r>
           </a:p>
         </p:txBody>
@@ -9382,7 +9630,7 @@
               </a:defRPr>
             </a:pPr>
             <a:r>
-              <a:t>Q&amp;A BACKUP  /  Xu Yiqun  /  XGBoost and cost analysis</a:t>
+              <a:t>Q&amp;A BACKUP  /  Xu Yiqun  /  XGBoost and threshold trade-offs</a:t>
             </a:r>
           </a:p>
         </p:txBody>
@@ -10710,7 +10958,7 @@
               </a:defRPr>
             </a:pPr>
             <a:r>
-              <a:t>Q&amp;A BACKUP  /  Zhou Xinzhe  /  Random forest and experiment audit</a:t>
+              <a:t>Q&amp;A BACKUP  /  Zhou Xinzhe  /  Random forest and error analysis</a:t>
             </a:r>
           </a:p>
         </p:txBody>
@@ -11205,7 +11453,7 @@
               </a:defRPr>
             </a:pPr>
             <a:r>
-              <a:t>Part 2 — Decision tree and model comparison</a:t>
+              <a:t>Part 2 — Decision tree and overfitting</a:t>
             </a:r>
           </a:p>
         </p:txBody>
@@ -11283,7 +11531,7 @@
               </a:defRPr>
             </a:pPr>
             <a:r>
-              <a:t>Part 3 — Random forest and experiment audit</a:t>
+              <a:t>Part 3 — Random forest and error analysis</a:t>
             </a:r>
           </a:p>
         </p:txBody>
@@ -11361,7 +11609,7 @@
               </a:defRPr>
             </a:pPr>
             <a:r>
-              <a:t>Part 4 — XGBoost and cost analysis</a:t>
+              <a:t>Part 4 — XGBoost and threshold trade-offs</a:t>
             </a:r>
           </a:p>
         </p:txBody>
@@ -13259,7 +13507,7 @@
               </a:defRPr>
             </a:pPr>
             <a:r>
-              <a:t>PART 2  /  Zhang Hanyu  /  Decision tree and model comparison</a:t>
+              <a:t>PART 2  /  Zhang Hanyu  /  Decision tree and overfitting</a:t>
             </a:r>
           </a:p>
         </p:txBody>
@@ -13817,7 +14065,7 @@
               </a:defRPr>
             </a:pPr>
             <a:r>
-              <a:t>PART 2  /  Zhang Hanyu  /  Decision tree and model comparison</a:t>
+              <a:t>PART 2  /  Zhang Hanyu  /  Decision tree and overfitting</a:t>
             </a:r>
           </a:p>
         </p:txBody>
@@ -14618,7 +14866,7 @@
               </a:defRPr>
             </a:pPr>
             <a:r>
-              <a:t>PART 2  /  Zhang Hanyu  /  Decision tree and model comparison</a:t>
+              <a:t>PART 2  /  Zhang Hanyu  /  Decision tree and overfitting</a:t>
             </a:r>
           </a:p>
         </p:txBody>
@@ -15176,7 +15424,7 @@
               </a:defRPr>
             </a:pPr>
             <a:r>
-              <a:t>PART 3  /  Zhou Xinzhe  /  Random forest and experiment audit</a:t>
+              <a:t>PART 3  /  Zhou Xinzhe  /  Random forest and error analysis</a:t>
             </a:r>
           </a:p>
         </p:txBody>
@@ -15734,7 +15982,7 @@
               </a:defRPr>
             </a:pPr>
             <a:r>
-              <a:t>PART 3  /  Zhou Xinzhe  /  Random forest and experiment audit</a:t>
+              <a:t>PART 3  /  Zhou Xinzhe  /  Random forest and error analysis</a:t>
             </a:r>
           </a:p>
         </p:txBody>
@@ -15773,7 +16021,7 @@
               </a:defRPr>
             </a:pPr>
             <a:r>
-              <a:t>Random forest: the review workload</a:t>
+              <a:t>Random forest: which features matter?</a:t>
             </a:r>
           </a:p>
         </p:txBody>
@@ -15822,47 +16070,65 @@
         </p:nvSpPr>
         <p:spPr>
           <a:xfrm>
-            <a:off x="658368" y="2167128"/>
-            <a:ext cx="4983480" cy="941832"/>
-          </a:xfrm>
-          <a:prstGeom prst="rect">
-            <a:avLst/>
-          </a:prstGeom>
-          <a:noFill/>
-        </p:spPr>
-        <p:txBody>
-          <a:bodyPr wrap="square" lIns="27432" rIns="27432" tIns="18288" bIns="18288">
-            <a:spAutoFit/>
-          </a:bodyPr>
-          <a:lstStyle/>
-          <a:p>
-            <a:pPr>
-              <a:spcAft>
-                <a:spcPts val="700"/>
-              </a:spcAft>
-              <a:defRPr sz="2300" b="0">
-                <a:solidFill>
-                  <a:srgbClr val="183447"/>
-                </a:solidFill>
-                <a:latin typeface="Arial"/>
-              </a:defRPr>
-            </a:pPr>
-            <a:r>
-              <a:t>Validation selected r=5 threshold: 0.3229</a:t>
-            </a:r>
-          </a:p>
-        </p:txBody>
-      </p:sp>
+            <a:off x="694944" y="1920240"/>
+            <a:ext cx="6492240" cy="320040"/>
+          </a:xfrm>
+          <a:prstGeom prst="rect">
+            <a:avLst/>
+          </a:prstGeom>
+          <a:noFill/>
+        </p:spPr>
+        <p:txBody>
+          <a:bodyPr wrap="square" lIns="27432" rIns="27432" tIns="18288" bIns="18288">
+            <a:spAutoFit/>
+          </a:bodyPr>
+          <a:lstStyle/>
+          <a:p>
+            <a:pPr>
+              <a:spcAft>
+                <a:spcPts val="700"/>
+              </a:spcAft>
+              <a:defRPr sz="1600" b="1">
+                <a:solidFill>
+                  <a:srgbClr val="187B78"/>
+                </a:solidFill>
+                <a:latin typeface="Arial"/>
+              </a:defRPr>
+            </a:pPr>
+            <a:r>
+              <a:t>Mean decrease in validation AP</a:t>
+            </a:r>
+          </a:p>
+        </p:txBody>
+      </p:sp>
+      <p:graphicFrame>
+        <p:nvGraphicFramePr>
+          <p:cNvPr id="6" name="Chart 5"/>
+          <p:cNvGraphicFramePr>
+            <a:graphicFrameLocks noGrp="1"/>
+          </p:cNvGraphicFramePr>
+          <p:nvPr/>
+        </p:nvGraphicFramePr>
+        <p:xfrm>
+          <a:off x="594360" y="2240280"/>
+          <a:ext cx="6675120" cy="3429000"/>
+        </p:xfrm>
+        <a:graphic>
+          <a:graphicData uri="http://schemas.openxmlformats.org/drawingml/2006/chart">
+            <c:chart xmlns:c="http://schemas.openxmlformats.org/drawingml/2006/chart" r:id="rId2"/>
+          </a:graphicData>
+        </a:graphic>
+      </p:graphicFrame>
       <p:cxnSp>
         <p:nvCxnSpPr>
-          <p:cNvPr id="6" name="Connector 5"/>
+          <p:cNvPr id="7" name="Connector 6"/>
           <p:cNvCxnSpPr/>
           <p:nvPr/>
         </p:nvCxnSpPr>
         <p:spPr>
           <a:xfrm>
-            <a:off x="685800" y="3154680"/>
-            <a:ext cx="4745736" cy="0"/>
+            <a:off x="7562088" y="2148840"/>
+            <a:ext cx="0" cy="3474720"/>
           </a:xfrm>
           <a:prstGeom prst="line">
             <a:avLst/>
@@ -15891,31 +16157,31 @@
       </p:cxnSp>
       <p:sp>
         <p:nvSpPr>
-          <p:cNvPr id="7" name="TextBox 6"/>
-          <p:cNvSpPr txBox="1"/>
-          <p:nvPr/>
-        </p:nvSpPr>
-        <p:spPr>
-          <a:xfrm>
-            <a:off x="658368" y="3282696"/>
-            <a:ext cx="4983480" cy="941832"/>
-          </a:xfrm>
-          <a:prstGeom prst="rect">
-            <a:avLst/>
-          </a:prstGeom>
-          <a:noFill/>
-        </p:spPr>
-        <p:txBody>
-          <a:bodyPr wrap="square" lIns="27432" rIns="27432" tIns="18288" bIns="18288">
-            <a:spAutoFit/>
-          </a:bodyPr>
-          <a:lstStyle/>
-          <a:p>
-            <a:pPr>
-              <a:spcAft>
-                <a:spcPts val="700"/>
-              </a:spcAft>
-              <a:defRPr sz="2300" b="0">
+          <p:cNvPr id="8" name="TextBox 7"/>
+          <p:cNvSpPr txBox="1"/>
+          <p:nvPr/>
+        </p:nvSpPr>
+        <p:spPr>
+          <a:xfrm>
+            <a:off x="7909560" y="2029968"/>
+            <a:ext cx="3639312" cy="813816"/>
+          </a:xfrm>
+          <a:prstGeom prst="rect">
+            <a:avLst/>
+          </a:prstGeom>
+          <a:noFill/>
+        </p:spPr>
+        <p:txBody>
+          <a:bodyPr wrap="square" lIns="27432" rIns="27432" tIns="18288" bIns="18288">
+            <a:spAutoFit/>
+          </a:bodyPr>
+          <a:lstStyle/>
+          <a:p>
+            <a:pPr>
+              <a:spcAft>
+                <a:spcPts val="700"/>
+              </a:spcAft>
+              <a:defRPr sz="2000" b="1">
                 <a:solidFill>
                   <a:srgbClr val="183447"/>
                 </a:solidFill>
@@ -15923,21 +16189,193 @@
               </a:defRPr>
             </a:pPr>
             <a:r>
-              <a:t>Recall: 52.0% → 77.1%</a:t>
+              <a:t>PAY_0 has the largest validation AP decrease</a:t>
+            </a:r>
+          </a:p>
+        </p:txBody>
+      </p:sp>
+      <p:sp>
+        <p:nvSpPr>
+          <p:cNvPr id="9" name="TextBox 8"/>
+          <p:cNvSpPr txBox="1"/>
+          <p:nvPr/>
+        </p:nvSpPr>
+        <p:spPr>
+          <a:xfrm>
+            <a:off x="7909560" y="2953512"/>
+            <a:ext cx="3639312" cy="813816"/>
+          </a:xfrm>
+          <a:prstGeom prst="rect">
+            <a:avLst/>
+          </a:prstGeom>
+          <a:noFill/>
+        </p:spPr>
+        <p:txBody>
+          <a:bodyPr wrap="square" lIns="27432" rIns="27432" tIns="18288" bIns="18288">
+            <a:spAutoFit/>
+          </a:bodyPr>
+          <a:lstStyle/>
+          <a:p>
+            <a:pPr>
+              <a:spcAft>
+                <a:spcPts val="700"/>
+              </a:spcAft>
+              <a:defRPr sz="2000" b="0">
+                <a:solidFill>
+                  <a:srgbClr val="183447"/>
+                </a:solidFill>
+                <a:latin typeface="Arial"/>
+              </a:defRPr>
+            </a:pPr>
+            <a:r>
+              <a:t>Permutation measures predictive reliance</a:t>
+            </a:r>
+          </a:p>
+        </p:txBody>
+      </p:sp>
+      <p:sp>
+        <p:nvSpPr>
+          <p:cNvPr id="10" name="TextBox 9"/>
+          <p:cNvSpPr txBox="1"/>
+          <p:nvPr/>
+        </p:nvSpPr>
+        <p:spPr>
+          <a:xfrm>
+            <a:off x="7909560" y="3877056"/>
+            <a:ext cx="3639312" cy="813816"/>
+          </a:xfrm>
+          <a:prstGeom prst="rect">
+            <a:avLst/>
+          </a:prstGeom>
+          <a:noFill/>
+        </p:spPr>
+        <p:txBody>
+          <a:bodyPr wrap="square" lIns="27432" rIns="27432" tIns="18288" bIns="18288">
+            <a:spAutoFit/>
+          </a:bodyPr>
+          <a:lstStyle/>
+          <a:p>
+            <a:pPr>
+              <a:spcAft>
+                <a:spcPts val="700"/>
+              </a:spcAft>
+              <a:defRPr sz="2000" b="0">
+                <a:solidFill>
+                  <a:srgbClr val="183447"/>
+                </a:solidFill>
+                <a:latin typeface="Arial"/>
+              </a:defRPr>
+            </a:pPr>
+            <a:r>
+              <a:t>Correlated variables can substitute for each other</a:t>
+            </a:r>
+          </a:p>
+        </p:txBody>
+      </p:sp>
+      <p:sp>
+        <p:nvSpPr>
+          <p:cNvPr id="11" name="TextBox 10"/>
+          <p:cNvSpPr txBox="1"/>
+          <p:nvPr/>
+        </p:nvSpPr>
+        <p:spPr>
+          <a:xfrm>
+            <a:off x="7909560" y="4965192"/>
+            <a:ext cx="3639312" cy="859536"/>
+          </a:xfrm>
+          <a:prstGeom prst="rect">
+            <a:avLst/>
+          </a:prstGeom>
+          <a:noFill/>
+        </p:spPr>
+        <p:txBody>
+          <a:bodyPr wrap="square" lIns="27432" rIns="27432" tIns="18288" bIns="18288">
+            <a:spAutoFit/>
+          </a:bodyPr>
+          <a:lstStyle/>
+          <a:p>
+            <a:pPr>
+              <a:spcAft>
+                <a:spcPts val="700"/>
+              </a:spcAft>
+              <a:defRPr sz="1500" b="0">
+                <a:solidFill>
+                  <a:srgbClr val="526575"/>
+                </a:solidFill>
+                <a:latin typeface="Arial"/>
+              </a:defRPr>
+            </a:pPr>
+            <a:r>
+              <a:t>Five saved shuffles per feature.</a:t>
+            </a:r>
+          </a:p>
+          <a:p>
+            <a:pPr>
+              <a:spcAft>
+                <a:spcPts val="700"/>
+              </a:spcAft>
+              <a:defRPr sz="1500" b="0">
+                <a:solidFill>
+                  <a:srgbClr val="526575"/>
+                </a:solidFill>
+                <a:latin typeface="Arial"/>
+              </a:defRPr>
+            </a:pPr>
+            <a:r>
+              <a:t>Predictive association, not causality.</a:t>
+            </a:r>
+          </a:p>
+        </p:txBody>
+      </p:sp>
+      <p:sp>
+        <p:nvSpPr>
+          <p:cNvPr id="12" name="TextBox 11"/>
+          <p:cNvSpPr txBox="1"/>
+          <p:nvPr/>
+        </p:nvSpPr>
+        <p:spPr>
+          <a:xfrm>
+            <a:off x="658368" y="6071616"/>
+            <a:ext cx="10652760" cy="347472"/>
+          </a:xfrm>
+          <a:prstGeom prst="rect">
+            <a:avLst/>
+          </a:prstGeom>
+          <a:noFill/>
+        </p:spPr>
+        <p:txBody>
+          <a:bodyPr wrap="square" lIns="27432" rIns="27432" tIns="18288" bIns="18288">
+            <a:spAutoFit/>
+          </a:bodyPr>
+          <a:lstStyle/>
+          <a:p>
+            <a:pPr>
+              <a:spcAft>
+                <a:spcPts val="700"/>
+              </a:spcAft>
+              <a:defRPr sz="1000" b="0">
+                <a:solidFill>
+                  <a:srgbClr val="526575"/>
+                </a:solidFill>
+                <a:latin typeface="Arial"/>
+              </a:defRPr>
+            </a:pPr>
+            <a:r>
+              <a:t>Source: results/rf/validation_importance.csv</a:t>
             </a:r>
           </a:p>
         </p:txBody>
       </p:sp>
       <p:cxnSp>
         <p:nvCxnSpPr>
-          <p:cNvPr id="8" name="Connector 7"/>
+          <p:cNvPr id="13" name="Connector 12"/>
           <p:cNvCxnSpPr/>
           <p:nvPr/>
         </p:nvCxnSpPr>
         <p:spPr>
           <a:xfrm>
-            <a:off x="685800" y="4270248"/>
-            <a:ext cx="4745736" cy="0"/>
+            <a:off x="667512" y="6483096"/>
+            <a:ext cx="10844784" cy="0"/>
           </a:xfrm>
           <a:prstGeom prst="line">
             <a:avLst/>
@@ -15966,303 +16404,7 @@
       </p:cxnSp>
       <p:sp>
         <p:nvSpPr>
-          <p:cNvPr id="9" name="TextBox 8"/>
-          <p:cNvSpPr txBox="1"/>
-          <p:nvPr/>
-        </p:nvSpPr>
-        <p:spPr>
-          <a:xfrm>
-            <a:off x="658368" y="4398264"/>
-            <a:ext cx="4983480" cy="941832"/>
-          </a:xfrm>
-          <a:prstGeom prst="rect">
-            <a:avLst/>
-          </a:prstGeom>
-          <a:noFill/>
-        </p:spPr>
-        <p:txBody>
-          <a:bodyPr wrap="square" lIns="27432" rIns="27432" tIns="18288" bIns="18288">
-            <a:spAutoFit/>
-          </a:bodyPr>
-          <a:lstStyle/>
-          <a:p>
-            <a:pPr>
-              <a:spcAft>
-                <a:spcPts val="700"/>
-              </a:spcAft>
-              <a:defRPr sz="2300" b="0">
-                <a:solidFill>
-                  <a:srgbClr val="183447"/>
-                </a:solidFill>
-                <a:latin typeface="Arial"/>
-              </a:defRPr>
-            </a:pPr>
-            <a:r>
-              <a:t>Alert rate: 21.1% → 48.4%</a:t>
-            </a:r>
-          </a:p>
-        </p:txBody>
-      </p:sp>
-      <p:cxnSp>
-        <p:nvCxnSpPr>
-          <p:cNvPr id="10" name="Connector 9"/>
-          <p:cNvCxnSpPr/>
-          <p:nvPr/>
-        </p:nvCxnSpPr>
-        <p:spPr>
-          <a:xfrm>
-            <a:off x="5870448" y="2194560"/>
-            <a:ext cx="0" cy="3429000"/>
-          </a:xfrm>
-          <a:prstGeom prst="line">
-            <a:avLst/>
-          </a:prstGeom>
-          <a:ln w="12700">
-            <a:solidFill>
-              <a:srgbClr val="E1E8E8"/>
-            </a:solidFill>
-          </a:ln>
-          <a:effectLst/>
-        </p:spPr>
-        <p:style>
-          <a:lnRef idx="2">
-            <a:schemeClr val="accent1"/>
-          </a:lnRef>
-          <a:fillRef idx="0">
-            <a:schemeClr val="accent1"/>
-          </a:fillRef>
-          <a:effectRef idx="0">
-            <a:schemeClr val="accent1"/>
-          </a:effectRef>
-          <a:fontRef idx="minor">
-            <a:schemeClr val="tx1"/>
-          </a:fontRef>
-        </p:style>
-      </p:cxnSp>
-      <p:sp>
-        <p:nvSpPr>
-          <p:cNvPr id="11" name="TextBox 10"/>
-          <p:cNvSpPr txBox="1"/>
-          <p:nvPr/>
-        </p:nvSpPr>
-        <p:spPr>
-          <a:xfrm>
-            <a:off x="6291072" y="2331720"/>
-            <a:ext cx="5029200" cy="1143000"/>
-          </a:xfrm>
-          <a:prstGeom prst="rect">
-            <a:avLst/>
-          </a:prstGeom>
-          <a:noFill/>
-        </p:spPr>
-        <p:txBody>
-          <a:bodyPr wrap="square" lIns="27432" rIns="27432" tIns="18288" bIns="18288">
-            <a:spAutoFit/>
-          </a:bodyPr>
-          <a:lstStyle/>
-          <a:p>
-            <a:pPr>
-              <a:spcAft>
-                <a:spcPts val="700"/>
-              </a:spcAft>
-              <a:defRPr sz="3100" b="1">
-                <a:solidFill>
-                  <a:srgbClr val="187B78"/>
-                </a:solidFill>
-                <a:latin typeface="Arial"/>
-              </a:defRPr>
-            </a:pPr>
-            <a:r>
-              <a:t>3,758 → 3,404</a:t>
-            </a:r>
-          </a:p>
-        </p:txBody>
-      </p:sp>
-      <p:cxnSp>
-        <p:nvCxnSpPr>
-          <p:cNvPr id="12" name="Connector 11"/>
-          <p:cNvCxnSpPr/>
-          <p:nvPr/>
-        </p:nvCxnSpPr>
-        <p:spPr>
-          <a:xfrm>
-            <a:off x="6327648" y="3685032"/>
-            <a:ext cx="1078992" cy="0"/>
-          </a:xfrm>
-          <a:prstGeom prst="line">
-            <a:avLst/>
-          </a:prstGeom>
-          <a:ln w="25400">
-            <a:solidFill>
-              <a:srgbClr val="187B78"/>
-            </a:solidFill>
-          </a:ln>
-          <a:effectLst/>
-        </p:spPr>
-        <p:style>
-          <a:lnRef idx="2">
-            <a:schemeClr val="accent1"/>
-          </a:lnRef>
-          <a:fillRef idx="0">
-            <a:schemeClr val="accent1"/>
-          </a:fillRef>
-          <a:effectRef idx="0">
-            <a:schemeClr val="accent1"/>
-          </a:effectRef>
-          <a:fontRef idx="minor">
-            <a:schemeClr val="tx1"/>
-          </a:fontRef>
-        </p:style>
-      </p:cxnSp>
-      <p:sp>
-        <p:nvSpPr>
-          <p:cNvPr id="13" name="TextBox 12"/>
-          <p:cNvSpPr txBox="1"/>
-          <p:nvPr/>
-        </p:nvSpPr>
-        <p:spPr>
-          <a:xfrm>
-            <a:off x="6291072" y="4023360"/>
-            <a:ext cx="5074920" cy="1600200"/>
-          </a:xfrm>
-          <a:prstGeom prst="rect">
-            <a:avLst/>
-          </a:prstGeom>
-          <a:noFill/>
-        </p:spPr>
-        <p:txBody>
-          <a:bodyPr wrap="square" lIns="27432" rIns="27432" tIns="18288" bIns="18288">
-            <a:spAutoFit/>
-          </a:bodyPr>
-          <a:lstStyle/>
-          <a:p>
-            <a:pPr>
-              <a:spcAft>
-                <a:spcPts val="700"/>
-              </a:spcAft>
-              <a:defRPr sz="2100" b="0">
-                <a:solidFill>
-                  <a:srgbClr val="526575"/>
-                </a:solidFill>
-                <a:latin typeface="Arial"/>
-              </a:defRPr>
-            </a:pPr>
-            <a:r>
-              <a:t>Test cost = FP + 5 × FN</a:t>
-            </a:r>
-          </a:p>
-          <a:p>
-            <a:pPr>
-              <a:spcAft>
-                <a:spcPts val="700"/>
-              </a:spcAft>
-              <a:defRPr sz="2100" b="0">
-                <a:solidFill>
-                  <a:srgbClr val="526575"/>
-                </a:solidFill>
-                <a:latin typeface="Arial"/>
-              </a:defRPr>
-            </a:pPr>
-            <a:r>
-              <a:t>Error cases checked under each policy</a:t>
-            </a:r>
-          </a:p>
-          <a:p>
-            <a:pPr>
-              <a:spcAft>
-                <a:spcPts val="700"/>
-              </a:spcAft>
-              <a:defRPr sz="2100" b="0">
-                <a:solidFill>
-                  <a:srgbClr val="526575"/>
-                </a:solidFill>
-                <a:latin typeface="Arial"/>
-              </a:defRPr>
-            </a:pPr>
-            <a:r>
-              <a:t>Same extreme cases can legitimately recur</a:t>
-            </a:r>
-          </a:p>
-        </p:txBody>
-      </p:sp>
-      <p:sp>
-        <p:nvSpPr>
           <p:cNvPr id="14" name="TextBox 13"/>
-          <p:cNvSpPr txBox="1"/>
-          <p:nvPr/>
-        </p:nvSpPr>
-        <p:spPr>
-          <a:xfrm>
-            <a:off x="658368" y="6071616"/>
-            <a:ext cx="10652760" cy="347472"/>
-          </a:xfrm>
-          <a:prstGeom prst="rect">
-            <a:avLst/>
-          </a:prstGeom>
-          <a:noFill/>
-        </p:spPr>
-        <p:txBody>
-          <a:bodyPr wrap="square" lIns="27432" rIns="27432" tIns="18288" bIns="18288">
-            <a:spAutoFit/>
-          </a:bodyPr>
-          <a:lstStyle/>
-          <a:p>
-            <a:pPr>
-              <a:spcAft>
-                <a:spcPts val="700"/>
-              </a:spcAft>
-              <a:defRPr sz="1000" b="0">
-                <a:solidFill>
-                  <a:srgbClr val="526575"/>
-                </a:solidFill>
-                <a:latin typeface="Arial"/>
-              </a:defRPr>
-            </a:pPr>
-            <a:r>
-              <a:t>Source: results/final/model_comparison.csv</a:t>
-            </a:r>
-          </a:p>
-        </p:txBody>
-      </p:sp>
-      <p:cxnSp>
-        <p:nvCxnSpPr>
-          <p:cNvPr id="15" name="Connector 14"/>
-          <p:cNvCxnSpPr/>
-          <p:nvPr/>
-        </p:nvCxnSpPr>
-        <p:spPr>
-          <a:xfrm>
-            <a:off x="667512" y="6483096"/>
-            <a:ext cx="10844784" cy="0"/>
-          </a:xfrm>
-          <a:prstGeom prst="line">
-            <a:avLst/>
-          </a:prstGeom>
-          <a:ln w="12700">
-            <a:solidFill>
-              <a:srgbClr val="E1E8E8"/>
-            </a:solidFill>
-          </a:ln>
-          <a:effectLst/>
-        </p:spPr>
-        <p:style>
-          <a:lnRef idx="2">
-            <a:schemeClr val="accent1"/>
-          </a:lnRef>
-          <a:fillRef idx="0">
-            <a:schemeClr val="accent1"/>
-          </a:fillRef>
-          <a:effectRef idx="0">
-            <a:schemeClr val="accent1"/>
-          </a:effectRef>
-          <a:fontRef idx="minor">
-            <a:schemeClr val="tx1"/>
-          </a:fontRef>
-        </p:style>
-      </p:cxnSp>
-      <p:sp>
-        <p:nvSpPr>
-          <p:cNvPr id="16" name="TextBox 15"/>
           <p:cNvSpPr txBox="1"/>
           <p:nvPr/>
         </p:nvSpPr>
@@ -16301,7 +16443,7 @@
       </p:sp>
       <p:sp>
         <p:nvSpPr>
-          <p:cNvPr id="17" name="TextBox 16"/>
+          <p:cNvPr id="15" name="TextBox 14"/>
           <p:cNvSpPr txBox="1"/>
           <p:nvPr/>
         </p:nvSpPr>
@@ -16398,7 +16540,7 @@
               </a:defRPr>
             </a:pPr>
             <a:r>
-              <a:t>PART 3  /  Zhou Xinzhe  /  Random forest and experiment audit</a:t>
+              <a:t>PART 3  /  Zhou Xinzhe  /  Random forest and error analysis</a:t>
             </a:r>
           </a:p>
         </p:txBody>
@@ -16437,7 +16579,7 @@
               </a:defRPr>
             </a:pPr>
             <a:r>
-              <a:t>What makes the comparison credible</a:t>
+              <a:t>Random forest: two illustrative errors</a:t>
             </a:r>
           </a:p>
         </p:txBody>
@@ -16512,7 +16654,7 @@
               </a:defRPr>
             </a:pPr>
             <a:r>
-              <a:t>Identical fit / validation / five-fold memberships</a:t>
+              <a:t>At 0.5: 637 missed defaults; 573 false alarms</a:t>
             </a:r>
           </a:p>
         </p:txBody>
@@ -16587,7 +16729,23 @@
               </a:defRPr>
             </a:pPr>
             <a:r>
-              <a:t>Metrics recomputed after row-ID alignment</a:t>
+              <a:t>Missed default · row 982</a:t>
+            </a:r>
+          </a:p>
+          <a:p>
+            <a:pPr>
+              <a:spcAft>
+                <a:spcPts val="700"/>
+              </a:spcAft>
+              <a:defRPr sz="2300" b="0">
+                <a:solidFill>
+                  <a:srgbClr val="183447"/>
+                </a:solidFill>
+                <a:latin typeface="Arial"/>
+              </a:defRPr>
+            </a:pPr>
+            <a:r>
+              <a:t>Score 0.1012; actual default = 1</a:t>
             </a:r>
           </a:p>
         </p:txBody>
@@ -16662,7 +16820,23 @@
               </a:defRPr>
             </a:pPr>
             <a:r>
-              <a:t>Frozen thresholds use score ≥ threshold at full precision</a:t>
+              <a:t>False alarm · row 28747</a:t>
+            </a:r>
+          </a:p>
+          <a:p>
+            <a:pPr>
+              <a:spcAft>
+                <a:spcPts val="700"/>
+              </a:spcAft>
+              <a:defRPr sz="2300" b="0">
+                <a:solidFill>
+                  <a:srgbClr val="183447"/>
+                </a:solidFill>
+                <a:latin typeface="Arial"/>
+              </a:defRPr>
+            </a:pPr>
+            <a:r>
+              <a:t>Score 0.9415; actual default = 0</a:t>
             </a:r>
           </a:p>
         </p:txBody>
@@ -16737,7 +16911,7 @@
               </a:defRPr>
             </a:pPr>
             <a:r>
-              <a:t>Shared evidence, different searches</a:t>
+              <a:t>Why the predictions can fail</a:t>
             </a:r>
           </a:p>
         </p:txBody>
@@ -16812,7 +16986,7 @@
               </a:defRPr>
             </a:pPr>
             <a:r>
-              <a:t>Shared data and objective</a:t>
+              <a:t>Missed default: PAY_0 = -2</a:t>
             </a:r>
           </a:p>
           <a:p>
@@ -16828,7 +17002,7 @@
               </a:defRPr>
             </a:pPr>
             <a:r>
-              <a:t>Different search budgets</a:t>
+              <a:t>False alarm: PAY_0 = 3</a:t>
             </a:r>
           </a:p>
           <a:p>
@@ -16843,8 +17017,21 @@
                 <a:latin typeface="Arial"/>
               </a:defRPr>
             </a:pPr>
-            <a:r>
-              <a:t>Historical exposure and LR* caveat remain</a:t>
+          </a:p>
+          <a:p>
+            <a:pPr>
+              <a:spcAft>
+                <a:spcPts val="700"/>
+              </a:spcAft>
+              <a:defRPr sz="2100" b="0">
+                <a:solidFill>
+                  <a:srgbClr val="526575"/>
+                </a:solidFill>
+                <a:latin typeface="Arial"/>
+              </a:defRPr>
+            </a:pPr>
+            <a:r>
+              <a:t>Illustrative extreme errors, not typical clients.</a:t>
             </a:r>
           </a:p>
         </p:txBody>
@@ -16883,7 +17070,7 @@
               </a:defRPr>
             </a:pPr>
             <a:r>
-              <a:t>Source: results/final/audit.json; integration/LOGISTIC_PROVENANCE.md</a:t>
+              <a:t>Source: results/rf/misclassification_cases_05.csv</a:t>
             </a:r>
           </a:p>
         </p:txBody>

</xml_diff>

<commit_message>
build: deliver reviewed Part 2 speaker edits without reverting the latest deck
</commit_message>
<xml_diff>
--- a/submission/Group5_Presentation.pptx
+++ b/submission/Group5_Presentation.pptx
@@ -2850,13 +2850,38 @@
           </a:p>
           <a:p>
             <a:r>
-              <a:t>Target: 65 seconds</a:t>
+              <a:t>Target: 50 seconds</a:t>
             </a:r>
           </a:p>
           <a:p/>
           <a:p>
             <a:r>
-              <a:t>A decision tree can fit very detailed partitions, which makes overfitting easy. Our baseline achieves nearly perfect fitting-fold AP but only about zero point three in cross-validation. The declared grid searches seven depth limits and three minimum leaf sizes, giving twenty-one configurations. The selected model requires at least one hundred observations in each leaf, although it has no explicit depth cap. Test AP rises from 0.2843 to 0.5221. This is a substantial change for this model and split. It supports regularization as an explanation, rather than treating training performance as evidence of generalization. Next, we inspect what the tree actually uses.</a:t>
+              <a:t>A decision tree can create very detailed splits, so it can easily overfit.</a:t>
+            </a:r>
+          </a:p>
+          <a:p>
+            <a:r>
+              <a:t>In our baseline model, the tree fits the training folds almost perfectly, but its cross-validation performance is much lower.</a:t>
+            </a:r>
+          </a:p>
+          <a:p>
+            <a:r>
+              <a:t>We therefore tested 21 combinations of maximum depth and minimum leaf size. The selected model requires at least 100 observations in each leaf, while keeping no explicit depth limit.</a:t>
+            </a:r>
+          </a:p>
+          <a:p>
+            <a:r>
+              <a:t>On the test set, average precision improves from 0.284 to 0.522.</a:t>
+            </a:r>
+          </a:p>
+          <a:p>
+            <a:r>
+              <a:t>So the key point is that controlling leaf size greatly improves the decision tree’s held-out performance on this split.</a:t>
+            </a:r>
+          </a:p>
+          <a:p>
+            <a:r>
+              <a:t>Next, I’ll show one of the main rules learned by this model.</a:t>
             </a:r>
           </a:p>
           <a:p/>
@@ -2948,13 +2973,38 @@
           </a:p>
           <a:p>
             <a:r>
-              <a:t>Target: 60 seconds</a:t>
+              <a:t>Target: 55 seconds</a:t>
             </a:r>
           </a:p>
           <a:p/>
           <a:p>
             <a:r>
-              <a:t>The selected tree begins with recent repayment status, PAY zero. Its root separates values at one point five. In the fitting sample, the default proportions are sixteen point five one percent on the left and seventy point one three percent on the right. This provides a concise description of an important predictive pattern. It does not mean repayment status causes the outcome, and node proportions are not a substitute for calibration analysis. The full selected tree still has depth eighteen and one hundred thirty-four leaves. We therefore use a representative rule rather than claiming the whole tree is a small explanation.</a:t>
+              <a:t>The selected tree starts with recent repayment status, PAY zero.</a:t>
+            </a:r>
+          </a:p>
+          <a:p>
+            <a:r>
+              <a:t>The root split is at 1.5. In the fitting sample, the default rate is about 16.5% on the left branch, compared with about 70.1% on the right branch.</a:t>
+            </a:r>
+          </a:p>
+          <a:p>
+            <a:r>
+              <a:t>This shows that recent repayment status is one of the strongest predictive signals used by the tree.</a:t>
+            </a:r>
+          </a:p>
+          <a:p>
+            <a:r>
+              <a:t>However, this is only an association in our fitted data. It does not mean repayment status directly causes default.</a:t>
+            </a:r>
+          </a:p>
+          <a:p>
+            <a:r>
+              <a:t>The full tree is still quite large, with depth 18 and 134 leaves, so this rule is just one representative example rather than a complete explanation of the model.</a:t>
+            </a:r>
+          </a:p>
+          <a:p>
+            <a:r>
+              <a:t>Next, we compare the tree with the other models using the same ranking metric.</a:t>
             </a:r>
           </a:p>
           <a:p/>
@@ -3046,13 +3096,38 @@
           </a:p>
           <a:p>
             <a:r>
-              <a:t>Target: 55 seconds</a:t>
+              <a:t>Target: 75 seconds</a:t>
             </a:r>
           </a:p>
           <a:p/>
           <a:p>
             <a:r>
-              <a:t>This comparison retains both the baseline and the cross-validation-selected model for each family. Average precision is a recall-increment weighted sum of precision, not the trapezoidal area sometimes also called PR-AUC. Our positive prevalence is approximately zero point two two, which gives useful context for these scores. The selected forest has AP 0.5508, and selected XGBoost has 0.5516. Those close point estimates do not establish superiority. The XGBoost baseline is numerically higher, but this retrospective observation does not authorize another selection round on test results. Zhou Xinzhe will now explain the forest, its feature importance, and examples of its errors.</a:t>
+              <a:t>Finally, we compare the effect of tuning across all four model families using test average precision.</a:t>
+            </a:r>
+          </a:p>
+          <a:p>
+            <a:r>
+              <a:t>The most noticeable result is the decision tree. Its AP increases substantially from 0.284 to 0.522 after tuning. In comparison, logistic regression stays around 0.497, and random forest improves only moderately. XGBoost changes very little.</a:t>
+            </a:r>
+          </a:p>
+          <a:p>
+            <a:r>
+              <a:t>In this comparison, the decision tree benefits the most from hyperparameter tuning, which is consistent with what we saw earlier: controlling tree complexity is especially important for reducing overfitting.</a:t>
+            </a:r>
+          </a:p>
+          <a:p>
+            <a:r>
+              <a:t>In terms of final ranking performance, the selected XGBoost and random forest models achieve AP values of 0.552 and 0.551 respectively. These values are extremely close, so we should not claim that one is clearly superior.</a:t>
+            </a:r>
+          </a:p>
+          <a:p>
+            <a:r>
+              <a:t>Also, model selection was based on cross-validation before evaluating the test set, so we do not re-select a model simply because a baseline happens to perform slightly better on the test data.</a:t>
+            </a:r>
+          </a:p>
+          <a:p>
+            <a:r>
+              <a:t>LR remains a separately labelled post-hoc supplement. Zhou Xinzhe will now explain random-forest tuning, feature importance and error cases.</a:t>
             </a:r>
           </a:p>
           <a:p/>
@@ -15073,7 +15148,7 @@
               </a:defRPr>
             </a:pPr>
             <a:r>
-              <a:t>AP emphasizes positive-class retrieval</a:t>
+              <a:t>Decision tree gains most on this split</a:t>
             </a:r>
           </a:p>
         </p:txBody>
@@ -15112,7 +15187,7 @@
               </a:defRPr>
             </a:pPr>
             <a:r>
-              <a:t>AP is not trapezoidal PR-AUC</a:t>
+              <a:t>RF and XGBoost have the highest selected AP</a:t>
             </a:r>
           </a:p>
         </p:txBody>
@@ -15151,7 +15226,7 @@
               </a:defRPr>
             </a:pPr>
             <a:r>
-              <a:t>CV selection precedes these test comparisons</a:t>
+              <a:t>CV selection precedes test comparison</a:t>
             </a:r>
           </a:p>
         </p:txBody>

</xml_diff>

<commit_message>
build: deliver an explicit conclusion and Q&A closing slide
</commit_message>
<xml_diff>
--- a/submission/Group5_Presentation.pptx
+++ b/submission/Group5_Presentation.pptx
@@ -2154,7 +2154,7 @@
           <a:lstStyle/>
           <a:p>
             <a:r>
-              <a:t>Slide 12: What the results mean for credit review</a:t>
+              <a:t>Slide 12: Conclusions &amp; Q&amp;A</a:t>
             </a:r>
           </a:p>
           <a:p>
@@ -8448,7 +8448,7 @@
               </a:defRPr>
             </a:pPr>
             <a:r>
-              <a:t>What the results mean for credit review</a:t>
+              <a:t>Conclusions &amp; Q&amp;A</a:t>
             </a:r>
           </a:p>
         </p:txBody>
@@ -8748,7 +8748,7 @@
               </a:defRPr>
             </a:pPr>
             <a:r>
-              <a:t>Discussion</a:t>
+              <a:t>Thank you</a:t>
             </a:r>
           </a:p>
         </p:txBody>
@@ -8823,7 +8823,7 @@
               </a:defRPr>
             </a:pPr>
             <a:r>
-              <a:t>Set realistic costs and review capacity.</a:t>
+              <a:t>Questions &amp; discussion</a:t>
             </a:r>
           </a:p>
           <a:p>
@@ -8838,8 +8838,37 @@
                 <a:latin typeface="Arial"/>
               </a:defRPr>
             </a:pPr>
-            <a:r>
-              <a:t>Validate the policy on fresh data.</a:t>
+          </a:p>
+          <a:p>
+            <a:pPr>
+              <a:spcAft>
+                <a:spcPts val="700"/>
+              </a:spcAft>
+              <a:defRPr sz="2100" b="0">
+                <a:solidFill>
+                  <a:srgbClr val="526575"/>
+                </a:solidFill>
+                <a:latin typeface="Arial"/>
+              </a:defRPr>
+            </a:pPr>
+            <a:r>
+              <a:t>Lei Peng · Zhang Hanyu</a:t>
+            </a:r>
+          </a:p>
+          <a:p>
+            <a:pPr>
+              <a:spcAft>
+                <a:spcPts val="700"/>
+              </a:spcAft>
+              <a:defRPr sz="2100" b="0">
+                <a:solidFill>
+                  <a:srgbClr val="526575"/>
+                </a:solidFill>
+                <a:latin typeface="Arial"/>
+              </a:defRPr>
+            </a:pPr>
+            <a:r>
+              <a:t>Zhou Xinzhe · Xu Yiqun</a:t>
             </a:r>
           </a:p>
         </p:txBody>

</xml_diff>